<commit_message>
Improve data quality handling and refresh results
</commit_message>
<xml_diff>
--- a/Freight_Rate_Prediction_Minimal.pptx
+++ b/Freight_Rate_Prediction_Minimal.pptx
@@ -2,21 +2,21 @@
 <file path=ppt/presentation.xml><?xml version="1.0" encoding="utf-8"?>
 <p:presentation xmlns:p="http://schemas.openxmlformats.org/presentationml/2006/main">
   <p:sldMasterIdLst>
-    <p:sldMasterId xmlns:r="http://schemas.openxmlformats.org/officeDocument/2006/relationships" id="2147483648" r:id="Rf53e8101a1424069"/>
+    <p:sldMasterId xmlns:r="http://schemas.openxmlformats.org/officeDocument/2006/relationships" id="2147483648" r:id="Re4b7769dab6e40d0"/>
   </p:sldMasterIdLst>
   <p:notesMasterIdLst>
-    <p:notesMasterId xmlns:r="http://schemas.openxmlformats.org/officeDocument/2006/relationships" r:id="Rcd4abb426ccf447d"/>
+    <p:notesMasterId xmlns:r="http://schemas.openxmlformats.org/officeDocument/2006/relationships" r:id="R7f8d570223bf4012"/>
   </p:notesMasterIdLst>
   <p:sldIdLst>
-    <p:sldId xmlns:r="http://schemas.openxmlformats.org/officeDocument/2006/relationships" id="256" r:id="Rcf86448669ed4023"/>
-    <p:sldId xmlns:r="http://schemas.openxmlformats.org/officeDocument/2006/relationships" id="257" r:id="R0c1a67bee5244fff"/>
-    <p:sldId xmlns:r="http://schemas.openxmlformats.org/officeDocument/2006/relationships" id="258" r:id="R04ccacafe2cb4690"/>
-    <p:sldId xmlns:r="http://schemas.openxmlformats.org/officeDocument/2006/relationships" id="259" r:id="Re599986d9dca435c"/>
-    <p:sldId xmlns:r="http://schemas.openxmlformats.org/officeDocument/2006/relationships" id="260" r:id="R69d14c9f3a364157"/>
-    <p:sldId xmlns:r="http://schemas.openxmlformats.org/officeDocument/2006/relationships" id="261" r:id="R371d5acc953b4483"/>
-    <p:sldId xmlns:r="http://schemas.openxmlformats.org/officeDocument/2006/relationships" id="262" r:id="R8378c8fa517e4155"/>
-    <p:sldId xmlns:r="http://schemas.openxmlformats.org/officeDocument/2006/relationships" id="263" r:id="R3dfecbeb1edf464c"/>
-    <p:sldId xmlns:r="http://schemas.openxmlformats.org/officeDocument/2006/relationships" id="264" r:id="Rcb64ec6250064ea7"/>
+    <p:sldId xmlns:r="http://schemas.openxmlformats.org/officeDocument/2006/relationships" id="256" r:id="R9208b840a92943e6"/>
+    <p:sldId xmlns:r="http://schemas.openxmlformats.org/officeDocument/2006/relationships" id="257" r:id="Ra694c0e29183432b"/>
+    <p:sldId xmlns:r="http://schemas.openxmlformats.org/officeDocument/2006/relationships" id="258" r:id="R3696cb473d2e49c7"/>
+    <p:sldId xmlns:r="http://schemas.openxmlformats.org/officeDocument/2006/relationships" id="259" r:id="R5eb5c174f1b64a0a"/>
+    <p:sldId xmlns:r="http://schemas.openxmlformats.org/officeDocument/2006/relationships" id="260" r:id="Ra43f9ee27af3400a"/>
+    <p:sldId xmlns:r="http://schemas.openxmlformats.org/officeDocument/2006/relationships" id="261" r:id="R87840e9199da4e1b"/>
+    <p:sldId xmlns:r="http://schemas.openxmlformats.org/officeDocument/2006/relationships" id="262" r:id="R4c99de28c07c48dc"/>
+    <p:sldId xmlns:r="http://schemas.openxmlformats.org/officeDocument/2006/relationships" id="263" r:id="R21f0a40fc70f42d1"/>
+    <p:sldId xmlns:r="http://schemas.openxmlformats.org/officeDocument/2006/relationships" id="264" r:id="R4e33995e43bf4e5d"/>
   </p:sldIdLst>
   <p:sldSz cx="12192000" cy="6858000"/>
   <p:notesSz cx="6858000" cy="9144000"/>
@@ -960,12 +960,7 @@
           </a:p>
           <a:p xmlns:a="http://schemas.openxmlformats.org/drawingml/2006/main">
             <a:r>
-              <a:t>- results/leaderboard_tuned.csv — tuned CatBoost, XGBoost, and LightGBM</a:t>
-            </a:r>
-          </a:p>
-          <a:p xmlns:a="http://schemas.openxmlformats.org/drawingml/2006/main">
-            <a:r>
-              <a:t>- results/final_selection.csv — Ridge result</a:t>
+              <a:t>- results/final_selection.csv — corrected single-model results</a:t>
             </a:r>
           </a:p>
           <a:p xmlns:a="http://schemas.openxmlformats.org/drawingml/2006/main">
@@ -1208,7 +1203,7 @@
   </p:cSld>
   <p:clrMap bg1="lt1" tx1="dk1" bg2="lt2" tx2="dk2" accent1="accent1" accent2="accent2" accent3="accent3" accent4="accent4" accent5="accent5" accent6="accent6" hlink="hlink" folHlink="folHlink"/>
   <p:sldLayoutIdLst>
-    <p:sldLayoutId xmlns:r="http://schemas.openxmlformats.org/officeDocument/2006/relationships" id="2147483649" r:id="R6009bcd8c2bb497f"/>
+    <p:sldLayoutId xmlns:r="http://schemas.openxmlformats.org/officeDocument/2006/relationships" id="2147483649" r:id="R20b210b569cd4cf5"/>
   </p:sldLayoutIdLst>
   <p:txStyles>
     <p:titleStyle>
@@ -1787,6 +1782,7 @@
           <a:lstStyle xmlns:a="http://schemas.openxmlformats.org/drawingml/2006/main"/>
           <a:p xmlns:a="http://schemas.openxmlformats.org/drawingml/2006/main">
             <a:pPr algn="l">
+              <a:buNone/>
               <a:defRPr sz="1650" b="1">
                 <a:solidFill>
                   <a:srgbClr val="2F7FF7"/>
@@ -1843,6 +1839,7 @@
           <a:lstStyle xmlns:a="http://schemas.openxmlformats.org/drawingml/2006/main"/>
           <a:p xmlns:a="http://schemas.openxmlformats.org/drawingml/2006/main">
             <a:pPr algn="l">
+              <a:buNone/>
               <a:defRPr sz="6300" b="1">
                 <a:solidFill>
                   <a:srgbClr val="111318"/>
@@ -1866,6 +1863,7 @@
           </a:p>
           <a:p xmlns:a="http://schemas.openxmlformats.org/drawingml/2006/main">
             <a:pPr algn="l">
+              <a:buNone/>
               <a:defRPr sz="6300" b="1">
                 <a:solidFill>
                   <a:srgbClr val="111318"/>
@@ -1922,6 +1920,7 @@
           <a:lstStyle xmlns:a="http://schemas.openxmlformats.org/drawingml/2006/main"/>
           <a:p xmlns:a="http://schemas.openxmlformats.org/drawingml/2006/main">
             <a:pPr algn="l">
+              <a:buNone/>
               <a:defRPr sz="2100" b="0">
                 <a:solidFill>
                   <a:srgbClr val="626A78"/>
@@ -2040,6 +2039,7 @@
           <a:lstStyle xmlns:a="http://schemas.openxmlformats.org/drawingml/2006/main"/>
           <a:p xmlns:a="http://schemas.openxmlformats.org/drawingml/2006/main">
             <a:pPr algn="l">
+              <a:buNone/>
               <a:defRPr sz="3900" b="1">
                 <a:solidFill>
                   <a:srgbClr val="111318"/>
@@ -2096,6 +2096,7 @@
           <a:lstStyle xmlns:a="http://schemas.openxmlformats.org/drawingml/2006/main"/>
           <a:p xmlns:a="http://schemas.openxmlformats.org/drawingml/2006/main">
             <a:pPr algn="r">
+              <a:buNone/>
               <a:defRPr sz="1350" b="0">
                 <a:solidFill>
                   <a:srgbClr val="626A78"/>
@@ -2121,7 +2122,7 @@
       </p:sp>
       <p:cxnSp>
         <p:nvCxnSpPr>
-          <p:cNvPr id="14" name=""/>
+          <p:cNvPr id="34" name=""/>
           <p:cNvCxnSpPr/>
           <p:nvPr/>
         </p:nvCxnSpPr>
@@ -2174,6 +2175,7 @@
           <a:lstStyle xmlns:a="http://schemas.openxmlformats.org/drawingml/2006/main"/>
           <a:p xmlns:a="http://schemas.openxmlformats.org/drawingml/2006/main">
             <a:pPr algn="l">
+              <a:buNone/>
               <a:defRPr sz="4950" b="1">
                 <a:solidFill>
                   <a:srgbClr val="111318"/>
@@ -2230,6 +2232,7 @@
           <a:lstStyle xmlns:a="http://schemas.openxmlformats.org/drawingml/2006/main"/>
           <a:p xmlns:a="http://schemas.openxmlformats.org/drawingml/2006/main">
             <a:pPr algn="l">
+              <a:buNone/>
               <a:defRPr sz="1875" b="0">
                 <a:solidFill>
                   <a:srgbClr val="626A78"/>
@@ -2286,6 +2289,7 @@
           <a:lstStyle xmlns:a="http://schemas.openxmlformats.org/drawingml/2006/main"/>
           <a:p xmlns:a="http://schemas.openxmlformats.org/drawingml/2006/main">
             <a:pPr algn="l">
+              <a:buNone/>
               <a:defRPr sz="2400" b="1">
                 <a:solidFill>
                   <a:srgbClr val="111318"/>
@@ -2342,6 +2346,7 @@
           <a:lstStyle xmlns:a="http://schemas.openxmlformats.org/drawingml/2006/main"/>
           <a:p xmlns:a="http://schemas.openxmlformats.org/drawingml/2006/main">
             <a:pPr algn="l">
+              <a:buNone/>
               <a:defRPr sz="4950" b="1">
                 <a:solidFill>
                   <a:srgbClr val="2F7FF7"/>
@@ -2398,6 +2403,7 @@
           <a:lstStyle xmlns:a="http://schemas.openxmlformats.org/drawingml/2006/main"/>
           <a:p xmlns:a="http://schemas.openxmlformats.org/drawingml/2006/main">
             <a:pPr algn="l">
+              <a:buNone/>
               <a:defRPr sz="1875" b="0">
                 <a:solidFill>
                   <a:srgbClr val="626A78"/>
@@ -2454,6 +2460,7 @@
           <a:lstStyle xmlns:a="http://schemas.openxmlformats.org/drawingml/2006/main"/>
           <a:p xmlns:a="http://schemas.openxmlformats.org/drawingml/2006/main">
             <a:pPr algn="l">
+              <a:buNone/>
               <a:defRPr sz="2400" b="1">
                 <a:solidFill>
                   <a:srgbClr val="111318"/>
@@ -2479,7 +2486,7 @@
       </p:sp>
       <p:cxnSp>
         <p:nvCxnSpPr>
-          <p:cNvPr id="21" name=""/>
+          <p:cNvPr id="41" name=""/>
           <p:cNvCxnSpPr/>
           <p:nvPr/>
         </p:nvCxnSpPr>
@@ -2532,6 +2539,7 @@
           <a:lstStyle xmlns:a="http://schemas.openxmlformats.org/drawingml/2006/main"/>
           <a:p xmlns:a="http://schemas.openxmlformats.org/drawingml/2006/main">
             <a:pPr algn="l">
+              <a:buNone/>
               <a:defRPr sz="2250" b="0">
                 <a:solidFill>
                   <a:srgbClr val="111318"/>
@@ -2617,6 +2625,7 @@
           <a:lstStyle xmlns:a="http://schemas.openxmlformats.org/drawingml/2006/main"/>
           <a:p xmlns:a="http://schemas.openxmlformats.org/drawingml/2006/main">
             <a:pPr algn="l">
+              <a:buNone/>
               <a:defRPr sz="3900" b="1">
                 <a:solidFill>
                   <a:srgbClr val="111318"/>
@@ -2673,6 +2682,7 @@
           <a:lstStyle xmlns:a="http://schemas.openxmlformats.org/drawingml/2006/main"/>
           <a:p xmlns:a="http://schemas.openxmlformats.org/drawingml/2006/main">
             <a:pPr algn="r">
+              <a:buNone/>
               <a:defRPr sz="1350" b="0">
                 <a:solidFill>
                   <a:srgbClr val="626A78"/>
@@ -2698,7 +2708,7 @@
       </p:sp>
       <p:cxnSp>
         <p:nvCxnSpPr>
-          <p:cNvPr id="11" name=""/>
+          <p:cNvPr id="23" name=""/>
           <p:cNvCxnSpPr/>
           <p:nvPr/>
         </p:nvCxnSpPr>
@@ -2751,6 +2761,7 @@
           <a:lstStyle xmlns:a="http://schemas.openxmlformats.org/drawingml/2006/main"/>
           <a:p xmlns:a="http://schemas.openxmlformats.org/drawingml/2006/main">
             <a:pPr algn="l">
+              <a:buNone/>
               <a:defRPr sz="2850" b="1">
                 <a:solidFill>
                   <a:srgbClr val="111318"/>
@@ -2807,6 +2818,7 @@
           <a:lstStyle xmlns:a="http://schemas.openxmlformats.org/drawingml/2006/main"/>
           <a:p xmlns:a="http://schemas.openxmlformats.org/drawingml/2006/main">
             <a:pPr algn="l">
+              <a:buNone/>
               <a:defRPr sz="2250" b="0">
                 <a:solidFill>
                   <a:srgbClr val="626A78"/>
@@ -2832,7 +2844,7 @@
       </p:sp>
       <p:cxnSp>
         <p:nvCxnSpPr>
-          <p:cNvPr id="14" name=""/>
+          <p:cNvPr id="26" name=""/>
           <p:cNvCxnSpPr/>
           <p:nvPr/>
         </p:nvCxnSpPr>
@@ -2885,6 +2897,7 @@
           <a:lstStyle xmlns:a="http://schemas.openxmlformats.org/drawingml/2006/main"/>
           <a:p xmlns:a="http://schemas.openxmlformats.org/drawingml/2006/main">
             <a:pPr algn="l">
+              <a:buNone/>
               <a:defRPr sz="1800" b="0">
                 <a:solidFill>
                   <a:srgbClr val="626A78"/>
@@ -2941,6 +2954,7 @@
           <a:lstStyle xmlns:a="http://schemas.openxmlformats.org/drawingml/2006/main"/>
           <a:p xmlns:a="http://schemas.openxmlformats.org/drawingml/2006/main">
             <a:pPr algn="l">
+              <a:buNone/>
               <a:defRPr sz="3450" b="1">
                 <a:solidFill>
                   <a:srgbClr val="2F7FF7"/>
@@ -3026,6 +3040,7 @@
           <a:lstStyle xmlns:a="http://schemas.openxmlformats.org/drawingml/2006/main"/>
           <a:p xmlns:a="http://schemas.openxmlformats.org/drawingml/2006/main">
             <a:pPr algn="l">
+              <a:buNone/>
               <a:defRPr sz="3900" b="1">
                 <a:solidFill>
                   <a:srgbClr val="111318"/>
@@ -3082,6 +3097,7 @@
           <a:lstStyle xmlns:a="http://schemas.openxmlformats.org/drawingml/2006/main"/>
           <a:p xmlns:a="http://schemas.openxmlformats.org/drawingml/2006/main">
             <a:pPr algn="r">
+              <a:buNone/>
               <a:defRPr sz="1350" b="0">
                 <a:solidFill>
                   <a:srgbClr val="626A78"/>
@@ -3107,7 +3123,7 @@
       </p:sp>
       <p:cxnSp>
         <p:nvCxnSpPr>
-          <p:cNvPr id="11" name=""/>
+          <p:cNvPr id="23" name=""/>
           <p:cNvCxnSpPr/>
           <p:nvPr/>
         </p:nvCxnSpPr>
@@ -3160,6 +3176,7 @@
           <a:lstStyle xmlns:a="http://schemas.openxmlformats.org/drawingml/2006/main"/>
           <a:p xmlns:a="http://schemas.openxmlformats.org/drawingml/2006/main">
             <a:pPr algn="l">
+              <a:buNone/>
               <a:defRPr sz="6900" b="1">
                 <a:solidFill>
                   <a:srgbClr val="2F7FF7"/>
@@ -3216,6 +3233,7 @@
           <a:lstStyle xmlns:a="http://schemas.openxmlformats.org/drawingml/2006/main"/>
           <a:p xmlns:a="http://schemas.openxmlformats.org/drawingml/2006/main">
             <a:pPr algn="l">
+              <a:buNone/>
               <a:defRPr sz="2100" b="0">
                 <a:solidFill>
                   <a:srgbClr val="626A78"/>
@@ -3241,7 +3259,7 @@
       </p:sp>
       <p:cxnSp>
         <p:nvCxnSpPr>
-          <p:cNvPr id="14" name=""/>
+          <p:cNvPr id="26" name=""/>
           <p:cNvCxnSpPr/>
           <p:nvPr/>
         </p:nvCxnSpPr>
@@ -3294,6 +3312,7 @@
           <a:lstStyle xmlns:a="http://schemas.openxmlformats.org/drawingml/2006/main"/>
           <a:p xmlns:a="http://schemas.openxmlformats.org/drawingml/2006/main">
             <a:pPr algn="l">
+              <a:buNone/>
               <a:defRPr sz="2550" b="1">
                 <a:solidFill>
                   <a:srgbClr val="111318"/>
@@ -3350,6 +3369,7 @@
           <a:lstStyle xmlns:a="http://schemas.openxmlformats.org/drawingml/2006/main"/>
           <a:p xmlns:a="http://schemas.openxmlformats.org/drawingml/2006/main">
             <a:pPr algn="l">
+              <a:buNone/>
               <a:defRPr sz="2250" b="0">
                 <a:solidFill>
                   <a:srgbClr val="111318"/>
@@ -3435,6 +3455,7 @@
           <a:lstStyle xmlns:a="http://schemas.openxmlformats.org/drawingml/2006/main"/>
           <a:p xmlns:a="http://schemas.openxmlformats.org/drawingml/2006/main">
             <a:pPr algn="l">
+              <a:buNone/>
               <a:defRPr sz="3900" b="1">
                 <a:solidFill>
                   <a:srgbClr val="111318"/>
@@ -3491,6 +3512,7 @@
           <a:lstStyle xmlns:a="http://schemas.openxmlformats.org/drawingml/2006/main"/>
           <a:p xmlns:a="http://schemas.openxmlformats.org/drawingml/2006/main">
             <a:pPr algn="r">
+              <a:buNone/>
               <a:defRPr sz="1350" b="0">
                 <a:solidFill>
                   <a:srgbClr val="626A78"/>
@@ -3516,7 +3538,7 @@
       </p:sp>
       <p:cxnSp>
         <p:nvCxnSpPr>
-          <p:cNvPr id="18" name=""/>
+          <p:cNvPr id="46" name=""/>
           <p:cNvCxnSpPr/>
           <p:nvPr/>
         </p:nvCxnSpPr>
@@ -3538,7 +3560,7 @@
       </p:cxnSp>
       <p:cxnSp>
         <p:nvCxnSpPr>
-          <p:cNvPr id="19" name=""/>
+          <p:cNvPr id="47" name=""/>
           <p:cNvCxnSpPr/>
           <p:nvPr/>
         </p:nvCxnSpPr>
@@ -3690,6 +3712,7 @@
           <a:lstStyle xmlns:a="http://schemas.openxmlformats.org/drawingml/2006/main"/>
           <a:p xmlns:a="http://schemas.openxmlformats.org/drawingml/2006/main">
             <a:pPr algn="l">
+              <a:buNone/>
               <a:defRPr sz="2400" b="1">
                 <a:solidFill>
                   <a:srgbClr val="111318"/>
@@ -3746,6 +3769,7 @@
           <a:lstStyle xmlns:a="http://schemas.openxmlformats.org/drawingml/2006/main"/>
           <a:p xmlns:a="http://schemas.openxmlformats.org/drawingml/2006/main">
             <a:pPr algn="l">
+              <a:buNone/>
               <a:defRPr sz="1875" b="0">
                 <a:solidFill>
                   <a:srgbClr val="2F7FF7"/>
@@ -3802,6 +3826,7 @@
           <a:lstStyle xmlns:a="http://schemas.openxmlformats.org/drawingml/2006/main"/>
           <a:p xmlns:a="http://schemas.openxmlformats.org/drawingml/2006/main">
             <a:pPr algn="l">
+              <a:buNone/>
               <a:defRPr sz="2400" b="1">
                 <a:solidFill>
                   <a:srgbClr val="111318"/>
@@ -3858,6 +3883,7 @@
           <a:lstStyle xmlns:a="http://schemas.openxmlformats.org/drawingml/2006/main"/>
           <a:p xmlns:a="http://schemas.openxmlformats.org/drawingml/2006/main">
             <a:pPr algn="l">
+              <a:buNone/>
               <a:defRPr sz="1875" b="0">
                 <a:solidFill>
                   <a:srgbClr val="2F7FF7"/>
@@ -3914,6 +3940,7 @@
           <a:lstStyle xmlns:a="http://schemas.openxmlformats.org/drawingml/2006/main"/>
           <a:p xmlns:a="http://schemas.openxmlformats.org/drawingml/2006/main">
             <a:pPr algn="l">
+              <a:buNone/>
               <a:defRPr sz="2400" b="1">
                 <a:solidFill>
                   <a:srgbClr val="111318"/>
@@ -3970,6 +3997,7 @@
           <a:lstStyle xmlns:a="http://schemas.openxmlformats.org/drawingml/2006/main"/>
           <a:p xmlns:a="http://schemas.openxmlformats.org/drawingml/2006/main">
             <a:pPr algn="l">
+              <a:buNone/>
               <a:defRPr sz="1875" b="0">
                 <a:solidFill>
                   <a:srgbClr val="2F7FF7"/>
@@ -3995,7 +4023,7 @@
       </p:sp>
       <p:cxnSp>
         <p:nvCxnSpPr>
-          <p:cNvPr id="29" name=""/>
+          <p:cNvPr id="57" name=""/>
           <p:cNvCxnSpPr/>
           <p:nvPr/>
         </p:nvCxnSpPr>
@@ -4048,6 +4076,7 @@
           <a:lstStyle xmlns:a="http://schemas.openxmlformats.org/drawingml/2006/main"/>
           <a:p xmlns:a="http://schemas.openxmlformats.org/drawingml/2006/main">
             <a:pPr algn="l">
+              <a:buNone/>
               <a:defRPr sz="2250" b="0">
                 <a:solidFill>
                   <a:srgbClr val="111318"/>
@@ -4066,7 +4095,7 @@
                 <a:ea typeface="Helvetica Neue"/>
                 <a:cs typeface="Helvetica Neue"/>
               </a:rPr>
-              <a:t>Target encoding was fitted separately inside each fold.</a:t>
+              <a:t>Target encoding and label screening used training rows only.</a:t>
             </a:r>
           </a:p>
         </p:txBody>
@@ -4133,6 +4162,7 @@
           <a:lstStyle xmlns:a="http://schemas.openxmlformats.org/drawingml/2006/main"/>
           <a:p xmlns:a="http://schemas.openxmlformats.org/drawingml/2006/main">
             <a:pPr algn="l">
+              <a:buNone/>
               <a:defRPr sz="3900" b="1">
                 <a:solidFill>
                   <a:srgbClr val="111318"/>
@@ -4189,6 +4219,7 @@
           <a:lstStyle xmlns:a="http://schemas.openxmlformats.org/drawingml/2006/main"/>
           <a:p xmlns:a="http://schemas.openxmlformats.org/drawingml/2006/main">
             <a:pPr algn="r">
+              <a:buNone/>
               <a:defRPr sz="1350" b="0">
                 <a:solidFill>
                   <a:srgbClr val="626A78"/>
@@ -4214,7 +4245,7 @@
       </p:sp>
       <p:cxnSp>
         <p:nvCxnSpPr>
-          <p:cNvPr id="19" name=""/>
+          <p:cNvPr id="49" name=""/>
           <p:cNvCxnSpPr/>
           <p:nvPr/>
         </p:nvCxnSpPr>
@@ -4267,6 +4298,7 @@
           <a:lstStyle xmlns:a="http://schemas.openxmlformats.org/drawingml/2006/main"/>
           <a:p xmlns:a="http://schemas.openxmlformats.org/drawingml/2006/main">
             <a:pPr algn="l">
+              <a:buNone/>
               <a:defRPr sz="1800" b="1">
                 <a:solidFill>
                   <a:srgbClr val="626A78"/>
@@ -4323,6 +4355,7 @@
           <a:lstStyle xmlns:a="http://schemas.openxmlformats.org/drawingml/2006/main"/>
           <a:p xmlns:a="http://schemas.openxmlformats.org/drawingml/2006/main">
             <a:pPr algn="r">
+              <a:buNone/>
               <a:defRPr sz="1800" b="1">
                 <a:solidFill>
                   <a:srgbClr val="626A78"/>
@@ -4379,6 +4412,7 @@
           <a:lstStyle xmlns:a="http://schemas.openxmlformats.org/drawingml/2006/main"/>
           <a:p xmlns:a="http://schemas.openxmlformats.org/drawingml/2006/main">
             <a:pPr algn="r">
+              <a:buNone/>
               <a:defRPr sz="1800" b="1">
                 <a:solidFill>
                   <a:srgbClr val="626A78"/>
@@ -4404,7 +4438,7 @@
       </p:sp>
       <p:cxnSp>
         <p:nvCxnSpPr>
-          <p:cNvPr id="23" name=""/>
+          <p:cNvPr id="53" name=""/>
           <p:cNvCxnSpPr/>
           <p:nvPr/>
         </p:nvCxnSpPr>
@@ -4457,6 +4491,7 @@
           <a:lstStyle xmlns:a="http://schemas.openxmlformats.org/drawingml/2006/main"/>
           <a:p xmlns:a="http://schemas.openxmlformats.org/drawingml/2006/main">
             <a:pPr algn="l">
+              <a:buNone/>
               <a:defRPr sz="2400" b="0">
                 <a:solidFill>
                   <a:srgbClr val="111318"/>
@@ -4513,6 +4548,7 @@
           <a:lstStyle xmlns:a="http://schemas.openxmlformats.org/drawingml/2006/main"/>
           <a:p xmlns:a="http://schemas.openxmlformats.org/drawingml/2006/main">
             <a:pPr algn="r">
+              <a:buNone/>
               <a:defRPr sz="2400" b="0">
                 <a:solidFill>
                   <a:srgbClr val="111318"/>
@@ -4569,6 +4605,7 @@
           <a:lstStyle xmlns:a="http://schemas.openxmlformats.org/drawingml/2006/main"/>
           <a:p xmlns:a="http://schemas.openxmlformats.org/drawingml/2006/main">
             <a:pPr algn="r">
+              <a:buNone/>
               <a:defRPr sz="2400" b="0">
                 <a:solidFill>
                   <a:srgbClr val="111318"/>
@@ -4594,7 +4631,7 @@
       </p:sp>
       <p:cxnSp>
         <p:nvCxnSpPr>
-          <p:cNvPr id="27" name=""/>
+          <p:cNvPr id="57" name=""/>
           <p:cNvCxnSpPr/>
           <p:nvPr/>
         </p:nvCxnSpPr>
@@ -4647,6 +4684,7 @@
           <a:lstStyle xmlns:a="http://schemas.openxmlformats.org/drawingml/2006/main"/>
           <a:p xmlns:a="http://schemas.openxmlformats.org/drawingml/2006/main">
             <a:pPr algn="l">
+              <a:buNone/>
               <a:defRPr sz="2400" b="1">
                 <a:solidFill>
                   <a:srgbClr val="111318"/>
@@ -4703,6 +4741,7 @@
           <a:lstStyle xmlns:a="http://schemas.openxmlformats.org/drawingml/2006/main"/>
           <a:p xmlns:a="http://schemas.openxmlformats.org/drawingml/2006/main">
             <a:pPr algn="r">
+              <a:buNone/>
               <a:defRPr sz="2400" b="1">
                 <a:solidFill>
                   <a:srgbClr val="111318"/>
@@ -4759,6 +4798,7 @@
           <a:lstStyle xmlns:a="http://schemas.openxmlformats.org/drawingml/2006/main"/>
           <a:p xmlns:a="http://schemas.openxmlformats.org/drawingml/2006/main">
             <a:pPr algn="r">
+              <a:buNone/>
               <a:defRPr sz="2400" b="1">
                 <a:solidFill>
                   <a:srgbClr val="2F7FF7"/>
@@ -4784,7 +4824,7 @@
       </p:sp>
       <p:cxnSp>
         <p:nvCxnSpPr>
-          <p:cNvPr id="31" name=""/>
+          <p:cNvPr id="61" name=""/>
           <p:cNvCxnSpPr/>
           <p:nvPr/>
         </p:nvCxnSpPr>
@@ -4837,6 +4877,7 @@
           <a:lstStyle xmlns:a="http://schemas.openxmlformats.org/drawingml/2006/main"/>
           <a:p xmlns:a="http://schemas.openxmlformats.org/drawingml/2006/main">
             <a:pPr algn="l">
+              <a:buNone/>
               <a:defRPr sz="2250" b="0">
                 <a:solidFill>
                   <a:srgbClr val="111318"/>
@@ -4922,6 +4963,7 @@
           <a:lstStyle xmlns:a="http://schemas.openxmlformats.org/drawingml/2006/main"/>
           <a:p xmlns:a="http://schemas.openxmlformats.org/drawingml/2006/main">
             <a:pPr algn="l">
+              <a:buNone/>
               <a:defRPr sz="3900" b="1">
                 <a:solidFill>
                   <a:srgbClr val="111318"/>
@@ -4940,7 +4982,7 @@
                 <a:ea typeface="Helvetica Neue"/>
                 <a:cs typeface="Helvetica Neue"/>
               </a:rPr>
-              <a:t>Complex models reached similar RMSE</a:t>
+              <a:t>The strongest models remain close</a:t>
             </a:r>
           </a:p>
         </p:txBody>
@@ -4978,6 +5020,7 @@
           <a:lstStyle xmlns:a="http://schemas.openxmlformats.org/drawingml/2006/main"/>
           <a:p xmlns:a="http://schemas.openxmlformats.org/drawingml/2006/main">
             <a:pPr algn="r">
+              <a:buNone/>
               <a:defRPr sz="1350" b="0">
                 <a:solidFill>
                   <a:srgbClr val="626A78"/>
@@ -5003,7 +5046,7 @@
       </p:sp>
       <p:cxnSp>
         <p:nvCxnSpPr>
-          <p:cNvPr id="22" name=""/>
+          <p:cNvPr id="58" name=""/>
           <p:cNvCxnSpPr/>
           <p:nvPr/>
         </p:nvCxnSpPr>
@@ -5056,6 +5099,7 @@
           <a:lstStyle xmlns:a="http://schemas.openxmlformats.org/drawingml/2006/main"/>
           <a:p xmlns:a="http://schemas.openxmlformats.org/drawingml/2006/main">
             <a:pPr algn="l">
+              <a:buNone/>
               <a:defRPr sz="1800" b="1">
                 <a:solidFill>
                   <a:srgbClr val="626A78"/>
@@ -5112,6 +5156,7 @@
           <a:lstStyle xmlns:a="http://schemas.openxmlformats.org/drawingml/2006/main"/>
           <a:p xmlns:a="http://schemas.openxmlformats.org/drawingml/2006/main">
             <a:pPr algn="r">
+              <a:buNone/>
               <a:defRPr sz="1800" b="1">
                 <a:solidFill>
                   <a:srgbClr val="626A78"/>
@@ -5137,7 +5182,7 @@
       </p:sp>
       <p:cxnSp>
         <p:nvCxnSpPr>
-          <p:cNvPr id="25" name=""/>
+          <p:cNvPr id="61" name=""/>
           <p:cNvCxnSpPr/>
           <p:nvPr/>
         </p:nvCxnSpPr>
@@ -5190,6 +5235,7 @@
           <a:lstStyle xmlns:a="http://schemas.openxmlformats.org/drawingml/2006/main"/>
           <a:p xmlns:a="http://schemas.openxmlformats.org/drawingml/2006/main">
             <a:pPr algn="l">
+              <a:buNone/>
               <a:defRPr sz="2250" b="0">
                 <a:solidFill>
                   <a:srgbClr val="111318"/>
@@ -5208,7 +5254,7 @@
                 <a:ea typeface="Helvetica Neue"/>
                 <a:cs typeface="Helvetica Neue"/>
               </a:rPr>
-              <a:t>CatBoost</a:t>
+              <a:t>LightGBM</a:t>
             </a:r>
           </a:p>
         </p:txBody>
@@ -5246,6 +5292,7 @@
           <a:lstStyle xmlns:a="http://schemas.openxmlformats.org/drawingml/2006/main"/>
           <a:p xmlns:a="http://schemas.openxmlformats.org/drawingml/2006/main">
             <a:pPr algn="r">
+              <a:buNone/>
               <a:defRPr sz="2250" b="1">
                 <a:solidFill>
                   <a:srgbClr val="111318"/>
@@ -5264,14 +5311,14 @@
                 <a:ea typeface="Helvetica Neue"/>
                 <a:cs typeface="Helvetica Neue"/>
               </a:rPr>
-              <a:t>631.6</a:t>
+              <a:t>629.9</a:t>
             </a:r>
           </a:p>
         </p:txBody>
       </p:sp>
       <p:cxnSp>
         <p:nvCxnSpPr>
-          <p:cNvPr id="28" name=""/>
+          <p:cNvPr id="64" name=""/>
           <p:cNvCxnSpPr/>
           <p:nvPr/>
         </p:nvCxnSpPr>
@@ -5324,6 +5371,7 @@
           <a:lstStyle xmlns:a="http://schemas.openxmlformats.org/drawingml/2006/main"/>
           <a:p xmlns:a="http://schemas.openxmlformats.org/drawingml/2006/main">
             <a:pPr algn="l">
+              <a:buNone/>
               <a:defRPr sz="2250" b="0">
                 <a:solidFill>
                   <a:srgbClr val="111318"/>
@@ -5342,7 +5390,7 @@
                 <a:ea typeface="Helvetica Neue"/>
                 <a:cs typeface="Helvetica Neue"/>
               </a:rPr>
-              <a:t>Ridge</a:t>
+              <a:t>CatBoost</a:t>
             </a:r>
           </a:p>
         </p:txBody>
@@ -5380,6 +5428,7 @@
           <a:lstStyle xmlns:a="http://schemas.openxmlformats.org/drawingml/2006/main"/>
           <a:p xmlns:a="http://schemas.openxmlformats.org/drawingml/2006/main">
             <a:pPr algn="r">
+              <a:buNone/>
               <a:defRPr sz="2250" b="0">
                 <a:solidFill>
                   <a:srgbClr val="111318"/>
@@ -5398,14 +5447,14 @@
                 <a:ea typeface="Helvetica Neue"/>
                 <a:cs typeface="Helvetica Neue"/>
               </a:rPr>
-              <a:t>633.2</a:t>
+              <a:t>630.1</a:t>
             </a:r>
           </a:p>
         </p:txBody>
       </p:sp>
       <p:cxnSp>
         <p:nvCxnSpPr>
-          <p:cNvPr id="31" name=""/>
+          <p:cNvPr id="67" name=""/>
           <p:cNvCxnSpPr/>
           <p:nvPr/>
         </p:nvCxnSpPr>
@@ -5458,6 +5507,7 @@
           <a:lstStyle xmlns:a="http://schemas.openxmlformats.org/drawingml/2006/main"/>
           <a:p xmlns:a="http://schemas.openxmlformats.org/drawingml/2006/main">
             <a:pPr algn="l">
+              <a:buNone/>
               <a:defRPr sz="2250" b="0">
                 <a:solidFill>
                   <a:srgbClr val="111318"/>
@@ -5476,7 +5526,7 @@
                 <a:ea typeface="Helvetica Neue"/>
                 <a:cs typeface="Helvetica Neue"/>
               </a:rPr>
-              <a:t>XGBoost</a:t>
+              <a:t>Ridge</a:t>
             </a:r>
           </a:p>
         </p:txBody>
@@ -5514,6 +5564,7 @@
           <a:lstStyle xmlns:a="http://schemas.openxmlformats.org/drawingml/2006/main"/>
           <a:p xmlns:a="http://schemas.openxmlformats.org/drawingml/2006/main">
             <a:pPr algn="r">
+              <a:buNone/>
               <a:defRPr sz="2250" b="0">
                 <a:solidFill>
                   <a:srgbClr val="111318"/>
@@ -5532,14 +5583,14 @@
                 <a:ea typeface="Helvetica Neue"/>
                 <a:cs typeface="Helvetica Neue"/>
               </a:rPr>
-              <a:t>635.2</a:t>
+              <a:t>631.6</a:t>
             </a:r>
           </a:p>
         </p:txBody>
       </p:sp>
       <p:cxnSp>
         <p:nvCxnSpPr>
-          <p:cNvPr id="34" name=""/>
+          <p:cNvPr id="70" name=""/>
           <p:cNvCxnSpPr/>
           <p:nvPr/>
         </p:nvCxnSpPr>
@@ -5592,6 +5643,7 @@
           <a:lstStyle xmlns:a="http://schemas.openxmlformats.org/drawingml/2006/main"/>
           <a:p xmlns:a="http://schemas.openxmlformats.org/drawingml/2006/main">
             <a:pPr algn="l">
+              <a:buNone/>
               <a:defRPr sz="2250" b="0">
                 <a:solidFill>
                   <a:srgbClr val="111318"/>
@@ -5610,7 +5662,7 @@
                 <a:ea typeface="Helvetica Neue"/>
                 <a:cs typeface="Helvetica Neue"/>
               </a:rPr>
-              <a:t>LightGBM</a:t>
+              <a:t>XGBoost</a:t>
             </a:r>
           </a:p>
         </p:txBody>
@@ -5648,6 +5700,7 @@
           <a:lstStyle xmlns:a="http://schemas.openxmlformats.org/drawingml/2006/main"/>
           <a:p xmlns:a="http://schemas.openxmlformats.org/drawingml/2006/main">
             <a:pPr algn="r">
+              <a:buNone/>
               <a:defRPr sz="2250" b="0">
                 <a:solidFill>
                   <a:srgbClr val="111318"/>
@@ -5666,14 +5719,14 @@
                 <a:ea typeface="Helvetica Neue"/>
                 <a:cs typeface="Helvetica Neue"/>
               </a:rPr>
-              <a:t>635.4</a:t>
+              <a:t>632.3</a:t>
             </a:r>
           </a:p>
         </p:txBody>
       </p:sp>
       <p:cxnSp>
         <p:nvCxnSpPr>
-          <p:cNvPr id="37" name=""/>
+          <p:cNvPr id="73" name=""/>
           <p:cNvCxnSpPr/>
           <p:nvPr/>
         </p:nvCxnSpPr>
@@ -5726,6 +5779,7 @@
           <a:lstStyle xmlns:a="http://schemas.openxmlformats.org/drawingml/2006/main"/>
           <a:p xmlns:a="http://schemas.openxmlformats.org/drawingml/2006/main">
             <a:pPr algn="l">
+              <a:buNone/>
               <a:defRPr sz="2100" b="0">
                 <a:solidFill>
                   <a:srgbClr val="626A78"/>
@@ -5744,7 +5798,7 @@
                 <a:ea typeface="Helvetica Neue"/>
                 <a:cs typeface="Helvetica Neue"/>
               </a:rPr>
-              <a:t>The strongest results fall within a narrow range: 631.6–635.4 RMSE.</a:t>
+              <a:t>The four models fall within 2.4 RMSE points.</a:t>
             </a:r>
           </a:p>
         </p:txBody>
@@ -5811,6 +5865,7 @@
           <a:lstStyle xmlns:a="http://schemas.openxmlformats.org/drawingml/2006/main"/>
           <a:p xmlns:a="http://schemas.openxmlformats.org/drawingml/2006/main">
             <a:pPr algn="l">
+              <a:buNone/>
               <a:defRPr sz="3900" b="1">
                 <a:solidFill>
                   <a:srgbClr val="111318"/>
@@ -5867,6 +5922,7 @@
           <a:lstStyle xmlns:a="http://schemas.openxmlformats.org/drawingml/2006/main"/>
           <a:p xmlns:a="http://schemas.openxmlformats.org/drawingml/2006/main">
             <a:pPr algn="r">
+              <a:buNone/>
               <a:defRPr sz="1350" b="0">
                 <a:solidFill>
                   <a:srgbClr val="626A78"/>
@@ -5892,7 +5948,7 @@
       </p:sp>
       <p:cxnSp>
         <p:nvCxnSpPr>
-          <p:cNvPr id="18" name=""/>
+          <p:cNvPr id="30" name=""/>
           <p:cNvCxnSpPr/>
           <p:nvPr/>
         </p:nvCxnSpPr>
@@ -5945,6 +6001,7 @@
           <a:lstStyle xmlns:a="http://schemas.openxmlformats.org/drawingml/2006/main"/>
           <a:p xmlns:a="http://schemas.openxmlformats.org/drawingml/2006/main">
             <a:pPr algn="l">
+              <a:buNone/>
               <a:defRPr sz="2550" b="1">
                 <a:solidFill>
                   <a:srgbClr val="2F7FF7"/>
@@ -6001,6 +6058,7 @@
           <a:lstStyle xmlns:a="http://schemas.openxmlformats.org/drawingml/2006/main"/>
           <a:p xmlns:a="http://schemas.openxmlformats.org/drawingml/2006/main">
             <a:pPr algn="l">
+              <a:buNone/>
               <a:defRPr sz="3450" b="1">
                 <a:solidFill>
                   <a:srgbClr val="111318"/>
@@ -6019,14 +6077,14 @@
                 <a:ea typeface="Helvetica Neue"/>
                 <a:cs typeface="Helvetica Neue"/>
               </a:rPr>
-              <a:t>CatBoost + Ridge + XGBoost</a:t>
+              <a:t>LightGBM + CatBoost + Ridge</a:t>
             </a:r>
           </a:p>
         </p:txBody>
       </p:sp>
       <p:cxnSp>
         <p:nvCxnSpPr>
-          <p:cNvPr id="21" name=""/>
+          <p:cNvPr id="33" name=""/>
           <p:cNvCxnSpPr/>
           <p:nvPr/>
         </p:nvCxnSpPr>
@@ -6079,6 +6137,7 @@
           <a:lstStyle xmlns:a="http://schemas.openxmlformats.org/drawingml/2006/main"/>
           <a:p xmlns:a="http://schemas.openxmlformats.org/drawingml/2006/main">
             <a:pPr algn="l">
+              <a:buNone/>
               <a:defRPr sz="1725" b="1">
                 <a:solidFill>
                   <a:srgbClr val="626A78"/>
@@ -6135,6 +6194,7 @@
           <a:lstStyle xmlns:a="http://schemas.openxmlformats.org/drawingml/2006/main"/>
           <a:p xmlns:a="http://schemas.openxmlformats.org/drawingml/2006/main">
             <a:pPr algn="l">
+              <a:buNone/>
               <a:defRPr sz="3900" b="1">
                 <a:solidFill>
                   <a:srgbClr val="111318"/>
@@ -6153,7 +6213,7 @@
                 <a:ea typeface="Helvetica Neue"/>
                 <a:cs typeface="Helvetica Neue"/>
               </a:rPr>
-              <a:t>631.7</a:t>
+              <a:t>629.3</a:t>
             </a:r>
           </a:p>
         </p:txBody>
@@ -6191,6 +6251,7 @@
           <a:lstStyle xmlns:a="http://schemas.openxmlformats.org/drawingml/2006/main"/>
           <a:p xmlns:a="http://schemas.openxmlformats.org/drawingml/2006/main">
             <a:pPr algn="l">
+              <a:buNone/>
               <a:defRPr sz="1725" b="1">
                 <a:solidFill>
                   <a:srgbClr val="626A78"/>
@@ -6247,6 +6308,7 @@
           <a:lstStyle xmlns:a="http://schemas.openxmlformats.org/drawingml/2006/main"/>
           <a:p xmlns:a="http://schemas.openxmlformats.org/drawingml/2006/main">
             <a:pPr algn="l">
+              <a:buNone/>
               <a:defRPr sz="3900" b="1">
                 <a:solidFill>
                   <a:srgbClr val="111318"/>
@@ -6265,7 +6327,7 @@
                 <a:ea typeface="Helvetica Neue"/>
                 <a:cs typeface="Helvetica Neue"/>
               </a:rPr>
-              <a:t>123.9</a:t>
+              <a:t>114.3</a:t>
             </a:r>
           </a:p>
         </p:txBody>
@@ -6303,6 +6365,7 @@
           <a:lstStyle xmlns:a="http://schemas.openxmlformats.org/drawingml/2006/main"/>
           <a:p xmlns:a="http://schemas.openxmlformats.org/drawingml/2006/main">
             <a:pPr algn="l">
+              <a:buNone/>
               <a:defRPr sz="1725" b="1">
                 <a:solidFill>
                   <a:srgbClr val="626A78"/>
@@ -6359,6 +6422,7 @@
           <a:lstStyle xmlns:a="http://schemas.openxmlformats.org/drawingml/2006/main"/>
           <a:p xmlns:a="http://schemas.openxmlformats.org/drawingml/2006/main">
             <a:pPr algn="l">
+              <a:buNone/>
               <a:defRPr sz="3900" b="1">
                 <a:solidFill>
                   <a:srgbClr val="111318"/>
@@ -6377,7 +6441,7 @@
                 <a:ea typeface="Helvetica Neue"/>
                 <a:cs typeface="Helvetica Neue"/>
               </a:rPr>
-              <a:t>5.6%</a:t>
+              <a:t>5.1%</a:t>
             </a:r>
           </a:p>
         </p:txBody>
@@ -6415,6 +6479,7 @@
           <a:lstStyle xmlns:a="http://schemas.openxmlformats.org/drawingml/2006/main"/>
           <a:p xmlns:a="http://schemas.openxmlformats.org/drawingml/2006/main">
             <a:pPr algn="l">
+              <a:buNone/>
               <a:defRPr sz="1725" b="1">
                 <a:solidFill>
                   <a:srgbClr val="626A78"/>
@@ -6471,6 +6536,7 @@
           <a:lstStyle xmlns:a="http://schemas.openxmlformats.org/drawingml/2006/main"/>
           <a:p xmlns:a="http://schemas.openxmlformats.org/drawingml/2006/main">
             <a:pPr algn="l">
+              <a:buNone/>
               <a:defRPr sz="3900" b="1">
                 <a:solidFill>
                   <a:srgbClr val="111318"/>
@@ -6489,7 +6555,7 @@
                 <a:ea typeface="Helvetica Neue"/>
                 <a:cs typeface="Helvetica Neue"/>
               </a:rPr>
-              <a:t>0.825</a:t>
+              <a:t>0.826</a:t>
             </a:r>
           </a:p>
         </p:txBody>
@@ -6527,6 +6593,7 @@
           <a:lstStyle xmlns:a="http://schemas.openxmlformats.org/drawingml/2006/main"/>
           <a:p xmlns:a="http://schemas.openxmlformats.org/drawingml/2006/main">
             <a:pPr algn="l">
+              <a:buNone/>
               <a:defRPr sz="2100" b="0">
                 <a:solidFill>
                   <a:srgbClr val="626A78"/>
@@ -6545,7 +6612,7 @@
                 <a:ea typeface="Helvetica Neue"/>
                 <a:cs typeface="Helvetica Neue"/>
               </a:rPr>
-              <a:t>The average narrowly outperformed the best single model on out-of-fold predictions.</a:t>
+              <a:t>The blend produced the lowest out-of-fold error.</a:t>
             </a:r>
           </a:p>
         </p:txBody>
@@ -6612,6 +6679,7 @@
           <a:lstStyle xmlns:a="http://schemas.openxmlformats.org/drawingml/2006/main"/>
           <a:p xmlns:a="http://schemas.openxmlformats.org/drawingml/2006/main">
             <a:pPr algn="l">
+              <a:buNone/>
               <a:defRPr sz="3900" b="1">
                 <a:solidFill>
                   <a:srgbClr val="111318"/>
@@ -6668,6 +6736,7 @@
           <a:lstStyle xmlns:a="http://schemas.openxmlformats.org/drawingml/2006/main"/>
           <a:p xmlns:a="http://schemas.openxmlformats.org/drawingml/2006/main">
             <a:pPr algn="r">
+              <a:buNone/>
               <a:defRPr sz="1350" b="0">
                 <a:solidFill>
                   <a:srgbClr val="626A78"/>
@@ -6693,7 +6762,7 @@
       </p:sp>
       <p:cxnSp>
         <p:nvCxnSpPr>
-          <p:cNvPr id="15" name=""/>
+          <p:cNvPr id="31" name=""/>
           <p:cNvCxnSpPr/>
           <p:nvPr/>
         </p:nvCxnSpPr>
@@ -6746,6 +6815,7 @@
           <a:lstStyle xmlns:a="http://schemas.openxmlformats.org/drawingml/2006/main"/>
           <a:p xmlns:a="http://schemas.openxmlformats.org/drawingml/2006/main">
             <a:pPr algn="l">
+              <a:buNone/>
               <a:defRPr sz="2550" b="1">
                 <a:solidFill>
                   <a:srgbClr val="111318"/>
@@ -6802,6 +6872,7 @@
           <a:lstStyle xmlns:a="http://schemas.openxmlformats.org/drawingml/2006/main"/>
           <a:p xmlns:a="http://schemas.openxmlformats.org/drawingml/2006/main">
             <a:pPr algn="l">
+              <a:buNone/>
               <a:defRPr sz="2100" b="1">
                 <a:solidFill>
                   <a:srgbClr val="2F7FF7"/>
@@ -6858,6 +6929,7 @@
           <a:lstStyle xmlns:a="http://schemas.openxmlformats.org/drawingml/2006/main"/>
           <a:p xmlns:a="http://schemas.openxmlformats.org/drawingml/2006/main">
             <a:pPr algn="l">
+              <a:buNone/>
               <a:defRPr sz="2250" b="0">
                 <a:solidFill>
                   <a:srgbClr val="111318"/>
@@ -6883,7 +6955,7 @@
       </p:sp>
       <p:cxnSp>
         <p:nvCxnSpPr>
-          <p:cNvPr id="19" name=""/>
+          <p:cNvPr id="35" name=""/>
           <p:cNvCxnSpPr/>
           <p:nvPr/>
         </p:nvCxnSpPr>
@@ -6905,7 +6977,7 @@
       </p:cxnSp>
       <p:cxnSp>
         <p:nvCxnSpPr>
-          <p:cNvPr id="20" name=""/>
+          <p:cNvPr id="36" name=""/>
           <p:cNvCxnSpPr/>
           <p:nvPr/>
         </p:nvCxnSpPr>
@@ -6958,6 +7030,7 @@
           <a:lstStyle xmlns:a="http://schemas.openxmlformats.org/drawingml/2006/main"/>
           <a:p xmlns:a="http://schemas.openxmlformats.org/drawingml/2006/main">
             <a:pPr algn="l">
+              <a:buNone/>
               <a:defRPr sz="2550" b="1">
                 <a:solidFill>
                   <a:srgbClr val="111318"/>
@@ -7014,6 +7087,7 @@
           <a:lstStyle xmlns:a="http://schemas.openxmlformats.org/drawingml/2006/main"/>
           <a:p xmlns:a="http://schemas.openxmlformats.org/drawingml/2006/main">
             <a:pPr algn="l">
+              <a:buNone/>
               <a:defRPr sz="2100" b="1">
                 <a:solidFill>
                   <a:srgbClr val="2F7FF7"/>
@@ -7070,6 +7144,7 @@
           <a:lstStyle xmlns:a="http://schemas.openxmlformats.org/drawingml/2006/main"/>
           <a:p xmlns:a="http://schemas.openxmlformats.org/drawingml/2006/main">
             <a:pPr algn="l">
+              <a:buNone/>
               <a:defRPr sz="2250" b="0">
                 <a:solidFill>
                   <a:srgbClr val="111318"/>
@@ -7126,6 +7201,7 @@
           <a:lstStyle xmlns:a="http://schemas.openxmlformats.org/drawingml/2006/main"/>
           <a:p xmlns:a="http://schemas.openxmlformats.org/drawingml/2006/main">
             <a:pPr algn="l">
+              <a:buNone/>
               <a:defRPr sz="2100" b="0">
                 <a:solidFill>
                   <a:srgbClr val="626A78"/>

</xml_diff>

<commit_message>
Benchmark native categorical model and refresh submission
</commit_message>
<xml_diff>
--- a/Freight_Rate_Prediction_Minimal.pptx
+++ b/Freight_Rate_Prediction_Minimal.pptx
@@ -2,21 +2,21 @@
 <file path=ppt/presentation.xml><?xml version="1.0" encoding="utf-8"?>
 <p:presentation xmlns:p="http://schemas.openxmlformats.org/presentationml/2006/main">
   <p:sldMasterIdLst>
-    <p:sldMasterId xmlns:r="http://schemas.openxmlformats.org/officeDocument/2006/relationships" id="2147483648" r:id="Re4b7769dab6e40d0"/>
+    <p:sldMasterId xmlns:r="http://schemas.openxmlformats.org/officeDocument/2006/relationships" id="2147483648" r:id="R7ed3162e6bb84f37"/>
   </p:sldMasterIdLst>
   <p:notesMasterIdLst>
-    <p:notesMasterId xmlns:r="http://schemas.openxmlformats.org/officeDocument/2006/relationships" r:id="R7f8d570223bf4012"/>
+    <p:notesMasterId xmlns:r="http://schemas.openxmlformats.org/officeDocument/2006/relationships" r:id="R4eb002b0f4424885"/>
   </p:notesMasterIdLst>
   <p:sldIdLst>
-    <p:sldId xmlns:r="http://schemas.openxmlformats.org/officeDocument/2006/relationships" id="256" r:id="R9208b840a92943e6"/>
-    <p:sldId xmlns:r="http://schemas.openxmlformats.org/officeDocument/2006/relationships" id="257" r:id="Ra694c0e29183432b"/>
-    <p:sldId xmlns:r="http://schemas.openxmlformats.org/officeDocument/2006/relationships" id="258" r:id="R3696cb473d2e49c7"/>
-    <p:sldId xmlns:r="http://schemas.openxmlformats.org/officeDocument/2006/relationships" id="259" r:id="R5eb5c174f1b64a0a"/>
-    <p:sldId xmlns:r="http://schemas.openxmlformats.org/officeDocument/2006/relationships" id="260" r:id="Ra43f9ee27af3400a"/>
-    <p:sldId xmlns:r="http://schemas.openxmlformats.org/officeDocument/2006/relationships" id="261" r:id="R87840e9199da4e1b"/>
-    <p:sldId xmlns:r="http://schemas.openxmlformats.org/officeDocument/2006/relationships" id="262" r:id="R4c99de28c07c48dc"/>
-    <p:sldId xmlns:r="http://schemas.openxmlformats.org/officeDocument/2006/relationships" id="263" r:id="R21f0a40fc70f42d1"/>
-    <p:sldId xmlns:r="http://schemas.openxmlformats.org/officeDocument/2006/relationships" id="264" r:id="R4e33995e43bf4e5d"/>
+    <p:sldId xmlns:r="http://schemas.openxmlformats.org/officeDocument/2006/relationships" id="256" r:id="R8a31018273954495"/>
+    <p:sldId xmlns:r="http://schemas.openxmlformats.org/officeDocument/2006/relationships" id="257" r:id="Rf411b1886d434e83"/>
+    <p:sldId xmlns:r="http://schemas.openxmlformats.org/officeDocument/2006/relationships" id="258" r:id="Rcc841ba790d447e4"/>
+    <p:sldId xmlns:r="http://schemas.openxmlformats.org/officeDocument/2006/relationships" id="259" r:id="R1083195135bb45b5"/>
+    <p:sldId xmlns:r="http://schemas.openxmlformats.org/officeDocument/2006/relationships" id="260" r:id="R0e54a8e872674091"/>
+    <p:sldId xmlns:r="http://schemas.openxmlformats.org/officeDocument/2006/relationships" id="261" r:id="R1231ebdadde94e42"/>
+    <p:sldId xmlns:r="http://schemas.openxmlformats.org/officeDocument/2006/relationships" id="262" r:id="Rd72ff2fdccad4bf1"/>
+    <p:sldId xmlns:r="http://schemas.openxmlformats.org/officeDocument/2006/relationships" id="263" r:id="R47dcc91601584559"/>
+    <p:sldId xmlns:r="http://schemas.openxmlformats.org/officeDocument/2006/relationships" id="264" r:id="R248075a88d744fb2"/>
   </p:sldIdLst>
   <p:sldSz cx="12192000" cy="6858000"/>
   <p:notesSz cx="6858000" cy="9144000"/>
@@ -1203,7 +1203,7 @@
   </p:cSld>
   <p:clrMap bg1="lt1" tx1="dk1" bg2="lt2" tx2="dk2" accent1="accent1" accent2="accent2" accent3="accent3" accent4="accent4" accent5="accent5" accent6="accent6" hlink="hlink" folHlink="folHlink"/>
   <p:sldLayoutIdLst>
-    <p:sldLayoutId xmlns:r="http://schemas.openxmlformats.org/officeDocument/2006/relationships" id="2147483649" r:id="R20b210b569cd4cf5"/>
+    <p:sldLayoutId xmlns:r="http://schemas.openxmlformats.org/officeDocument/2006/relationships" id="2147483649" r:id="Rc0dcbf60f5894534"/>
   </p:sldLayoutIdLst>
   <p:txStyles>
     <p:titleStyle>
@@ -2122,7 +2122,7 @@
       </p:sp>
       <p:cxnSp>
         <p:nvCxnSpPr>
-          <p:cNvPr id="34" name=""/>
+          <p:cNvPr id="54" name=""/>
           <p:cNvCxnSpPr/>
           <p:nvPr/>
         </p:nvCxnSpPr>
@@ -2486,7 +2486,7 @@
       </p:sp>
       <p:cxnSp>
         <p:nvCxnSpPr>
-          <p:cNvPr id="41" name=""/>
+          <p:cNvPr id="61" name=""/>
           <p:cNvCxnSpPr/>
           <p:nvPr/>
         </p:nvCxnSpPr>
@@ -2708,7 +2708,7 @@
       </p:sp>
       <p:cxnSp>
         <p:nvCxnSpPr>
-          <p:cNvPr id="23" name=""/>
+          <p:cNvPr id="35" name=""/>
           <p:cNvCxnSpPr/>
           <p:nvPr/>
         </p:nvCxnSpPr>
@@ -2844,7 +2844,7 @@
       </p:sp>
       <p:cxnSp>
         <p:nvCxnSpPr>
-          <p:cNvPr id="26" name=""/>
+          <p:cNvPr id="38" name=""/>
           <p:cNvCxnSpPr/>
           <p:nvPr/>
         </p:nvCxnSpPr>
@@ -3123,7 +3123,7 @@
       </p:sp>
       <p:cxnSp>
         <p:nvCxnSpPr>
-          <p:cNvPr id="23" name=""/>
+          <p:cNvPr id="35" name=""/>
           <p:cNvCxnSpPr/>
           <p:nvPr/>
         </p:nvCxnSpPr>
@@ -3259,7 +3259,7 @@
       </p:sp>
       <p:cxnSp>
         <p:nvCxnSpPr>
-          <p:cNvPr id="26" name=""/>
+          <p:cNvPr id="38" name=""/>
           <p:cNvCxnSpPr/>
           <p:nvPr/>
         </p:nvCxnSpPr>
@@ -3538,7 +3538,7 @@
       </p:sp>
       <p:cxnSp>
         <p:nvCxnSpPr>
-          <p:cNvPr id="46" name=""/>
+          <p:cNvPr id="74" name=""/>
           <p:cNvCxnSpPr/>
           <p:nvPr/>
         </p:nvCxnSpPr>
@@ -3560,7 +3560,7 @@
       </p:cxnSp>
       <p:cxnSp>
         <p:nvCxnSpPr>
-          <p:cNvPr id="47" name=""/>
+          <p:cNvPr id="75" name=""/>
           <p:cNvCxnSpPr/>
           <p:nvPr/>
         </p:nvCxnSpPr>
@@ -4023,7 +4023,7 @@
       </p:sp>
       <p:cxnSp>
         <p:nvCxnSpPr>
-          <p:cNvPr id="57" name=""/>
+          <p:cNvPr id="85" name=""/>
           <p:cNvCxnSpPr/>
           <p:nvPr/>
         </p:nvCxnSpPr>
@@ -4245,7 +4245,7 @@
       </p:sp>
       <p:cxnSp>
         <p:nvCxnSpPr>
-          <p:cNvPr id="49" name=""/>
+          <p:cNvPr id="79" name=""/>
           <p:cNvCxnSpPr/>
           <p:nvPr/>
         </p:nvCxnSpPr>
@@ -4438,7 +4438,7 @@
       </p:sp>
       <p:cxnSp>
         <p:nvCxnSpPr>
-          <p:cNvPr id="53" name=""/>
+          <p:cNvPr id="83" name=""/>
           <p:cNvCxnSpPr/>
           <p:nvPr/>
         </p:nvCxnSpPr>
@@ -4631,7 +4631,7 @@
       </p:sp>
       <p:cxnSp>
         <p:nvCxnSpPr>
-          <p:cNvPr id="57" name=""/>
+          <p:cNvPr id="87" name=""/>
           <p:cNvCxnSpPr/>
           <p:nvPr/>
         </p:nvCxnSpPr>
@@ -4824,7 +4824,7 @@
       </p:sp>
       <p:cxnSp>
         <p:nvCxnSpPr>
-          <p:cNvPr id="61" name=""/>
+          <p:cNvPr id="91" name=""/>
           <p:cNvCxnSpPr/>
           <p:nvPr/>
         </p:nvCxnSpPr>
@@ -4982,7 +4982,7 @@
                 <a:ea typeface="Helvetica Neue"/>
                 <a:cs typeface="Helvetica Neue"/>
               </a:rPr>
-              <a:t>The strongest models remain close</a:t>
+              <a:t>Native categories gave the best RMSE</a:t>
             </a:r>
           </a:p>
         </p:txBody>
@@ -5046,7 +5046,7 @@
       </p:sp>
       <p:cxnSp>
         <p:nvCxnSpPr>
-          <p:cNvPr id="58" name=""/>
+          <p:cNvPr id="94" name=""/>
           <p:cNvCxnSpPr/>
           <p:nvPr/>
         </p:nvCxnSpPr>
@@ -5182,7 +5182,7 @@
       </p:sp>
       <p:cxnSp>
         <p:nvCxnSpPr>
-          <p:cNvPr id="61" name=""/>
+          <p:cNvPr id="97" name=""/>
           <p:cNvCxnSpPr/>
           <p:nvPr/>
         </p:nvCxnSpPr>
@@ -5254,7 +5254,7 @@
                 <a:ea typeface="Helvetica Neue"/>
                 <a:cs typeface="Helvetica Neue"/>
               </a:rPr>
-              <a:t>LightGBM</a:t>
+              <a:t>Native LightGBM</a:t>
             </a:r>
           </a:p>
         </p:txBody>
@@ -5311,14 +5311,14 @@
                 <a:ea typeface="Helvetica Neue"/>
                 <a:cs typeface="Helvetica Neue"/>
               </a:rPr>
-              <a:t>629.9</a:t>
+              <a:t>628.7</a:t>
             </a:r>
           </a:p>
         </p:txBody>
       </p:sp>
       <p:cxnSp>
         <p:nvCxnSpPr>
-          <p:cNvPr id="64" name=""/>
+          <p:cNvPr id="100" name=""/>
           <p:cNvCxnSpPr/>
           <p:nvPr/>
         </p:nvCxnSpPr>
@@ -5390,7 +5390,7 @@
                 <a:ea typeface="Helvetica Neue"/>
                 <a:cs typeface="Helvetica Neue"/>
               </a:rPr>
-              <a:t>CatBoost</a:t>
+              <a:t>Three-model blend</a:t>
             </a:r>
           </a:p>
         </p:txBody>
@@ -5447,14 +5447,14 @@
                 <a:ea typeface="Helvetica Neue"/>
                 <a:cs typeface="Helvetica Neue"/>
               </a:rPr>
-              <a:t>630.1</a:t>
+              <a:t>629.0</a:t>
             </a:r>
           </a:p>
         </p:txBody>
       </p:sp>
       <p:cxnSp>
         <p:nvCxnSpPr>
-          <p:cNvPr id="67" name=""/>
+          <p:cNvPr id="103" name=""/>
           <p:cNvCxnSpPr/>
           <p:nvPr/>
         </p:nvCxnSpPr>
@@ -5526,7 +5526,7 @@
                 <a:ea typeface="Helvetica Neue"/>
                 <a:cs typeface="Helvetica Neue"/>
               </a:rPr>
-              <a:t>Ridge</a:t>
+              <a:t>LightGBM</a:t>
             </a:r>
           </a:p>
         </p:txBody>
@@ -5583,14 +5583,14 @@
                 <a:ea typeface="Helvetica Neue"/>
                 <a:cs typeface="Helvetica Neue"/>
               </a:rPr>
-              <a:t>631.6</a:t>
+              <a:t>629.9</a:t>
             </a:r>
           </a:p>
         </p:txBody>
       </p:sp>
       <p:cxnSp>
         <p:nvCxnSpPr>
-          <p:cNvPr id="70" name=""/>
+          <p:cNvPr id="106" name=""/>
           <p:cNvCxnSpPr/>
           <p:nvPr/>
         </p:nvCxnSpPr>
@@ -5662,7 +5662,7 @@
                 <a:ea typeface="Helvetica Neue"/>
                 <a:cs typeface="Helvetica Neue"/>
               </a:rPr>
-              <a:t>XGBoost</a:t>
+              <a:t>CatBoost</a:t>
             </a:r>
           </a:p>
         </p:txBody>
@@ -5719,14 +5719,14 @@
                 <a:ea typeface="Helvetica Neue"/>
                 <a:cs typeface="Helvetica Neue"/>
               </a:rPr>
-              <a:t>632.3</a:t>
+              <a:t>630.1</a:t>
             </a:r>
           </a:p>
         </p:txBody>
       </p:sp>
       <p:cxnSp>
         <p:nvCxnSpPr>
-          <p:cNvPr id="73" name=""/>
+          <p:cNvPr id="109" name=""/>
           <p:cNvCxnSpPr/>
           <p:nvPr/>
         </p:nvCxnSpPr>
@@ -5798,7 +5798,7 @@
                 <a:ea typeface="Helvetica Neue"/>
                 <a:cs typeface="Helvetica Neue"/>
               </a:rPr>
-              <a:t>The four models fall within 2.4 RMSE points.</a:t>
+              <a:t>Native categories beat the best blend by 0.3 RMSE.</a:t>
             </a:r>
           </a:p>
         </p:txBody>
@@ -5948,7 +5948,7 @@
       </p:sp>
       <p:cxnSp>
         <p:nvCxnSpPr>
-          <p:cNvPr id="30" name=""/>
+          <p:cNvPr id="42" name=""/>
           <p:cNvCxnSpPr/>
           <p:nvPr/>
         </p:nvCxnSpPr>
@@ -6020,7 +6020,7 @@
                 <a:ea typeface="Helvetica Neue"/>
                 <a:cs typeface="Helvetica Neue"/>
               </a:rPr>
-              <a:t>Equal-weight average</a:t>
+              <a:t>Single model</a:t>
             </a:r>
           </a:p>
         </p:txBody>
@@ -6077,14 +6077,14 @@
                 <a:ea typeface="Helvetica Neue"/>
                 <a:cs typeface="Helvetica Neue"/>
               </a:rPr>
-              <a:t>LightGBM + CatBoost + Ridge</a:t>
+              <a:t>Native-categorical LightGBM</a:t>
             </a:r>
           </a:p>
         </p:txBody>
       </p:sp>
       <p:cxnSp>
         <p:nvCxnSpPr>
-          <p:cNvPr id="33" name=""/>
+          <p:cNvPr id="45" name=""/>
           <p:cNvCxnSpPr/>
           <p:nvPr/>
         </p:nvCxnSpPr>
@@ -6213,7 +6213,7 @@
                 <a:ea typeface="Helvetica Neue"/>
                 <a:cs typeface="Helvetica Neue"/>
               </a:rPr>
-              <a:t>629.3</a:t>
+              <a:t>628.7</a:t>
             </a:r>
           </a:p>
         </p:txBody>
@@ -6327,7 +6327,7 @@
                 <a:ea typeface="Helvetica Neue"/>
                 <a:cs typeface="Helvetica Neue"/>
               </a:rPr>
-              <a:t>114.3</a:t>
+              <a:t>113.8</a:t>
             </a:r>
           </a:p>
         </p:txBody>
@@ -6441,7 +6441,7 @@
                 <a:ea typeface="Helvetica Neue"/>
                 <a:cs typeface="Helvetica Neue"/>
               </a:rPr>
-              <a:t>5.1%</a:t>
+              <a:t>5.11%</a:t>
             </a:r>
           </a:p>
         </p:txBody>
@@ -6555,7 +6555,7 @@
                 <a:ea typeface="Helvetica Neue"/>
                 <a:cs typeface="Helvetica Neue"/>
               </a:rPr>
-              <a:t>0.826</a:t>
+              <a:t>0.8265</a:t>
             </a:r>
           </a:p>
         </p:txBody>
@@ -6612,7 +6612,7 @@
                 <a:ea typeface="Helvetica Neue"/>
                 <a:cs typeface="Helvetica Neue"/>
               </a:rPr>
-              <a:t>The blend produced the lowest out-of-fold error.</a:t>
+              <a:t>Native categories produced the lowest out-of-fold error.</a:t>
             </a:r>
           </a:p>
         </p:txBody>
@@ -6762,7 +6762,7 @@
       </p:sp>
       <p:cxnSp>
         <p:nvCxnSpPr>
-          <p:cNvPr id="31" name=""/>
+          <p:cNvPr id="47" name=""/>
           <p:cNvCxnSpPr/>
           <p:nvPr/>
         </p:nvCxnSpPr>
@@ -6948,14 +6948,14 @@
                 <a:ea typeface="Helvetica Neue"/>
                 <a:cs typeface="Helvetica Neue"/>
               </a:rPr>
-              <a:t>Used all available columns and the three-model average.</a:t>
+              <a:t>Used all columns and the selected native LightGBM model.</a:t>
             </a:r>
           </a:p>
         </p:txBody>
       </p:sp>
       <p:cxnSp>
         <p:nvCxnSpPr>
-          <p:cNvPr id="35" name=""/>
+          <p:cNvPr id="51" name=""/>
           <p:cNvCxnSpPr/>
           <p:nvPr/>
         </p:nvCxnSpPr>
@@ -6977,7 +6977,7 @@
       </p:cxnSp>
       <p:cxnSp>
         <p:nvCxnSpPr>
-          <p:cNvPr id="36" name=""/>
+          <p:cNvPr id="52" name=""/>
           <p:cNvCxnSpPr/>
           <p:nvPr/>
         </p:nvCxnSpPr>

</xml_diff>